<commit_message>
purge: remove ALL Bihar/Patna refs — Bengaluru/Karnataka everywhere; delete Bihar-edition builders+docx
</commit_message>
<xml_diff>
--- a/outputs/goc/SIA_AI_PITCH_DECK.pptx
+++ b/outputs/goc/SIA_AI_PITCH_DECK.pptx
@@ -4600,7 +4600,7 @@
               </a:defRPr>
             </a:pPr>
             <a:r>
-              <a:t>•  Bihar Startup Policy — Patna-based entity</a:t>
+              <a:t>•  Karnataka Startup/IT policy — Bengaluru-based entity</a:t>
             </a:r>
           </a:p>
         </p:txBody>
@@ -4951,7 +4951,7 @@
               </a:defRPr>
             </a:pPr>
             <a:r>
-              <a:t>•  Incubator partner: 51 TIDE incubators — Bihar/Bengaluru</a:t>
+              <a:t>•  Incubator partner: 51 TIDE incubators — Bengaluru</a:t>
             </a:r>
           </a:p>
         </p:txBody>

</xml_diff>